<commit_message>
BP v27: language polish across all pages
43 copy edits from a page-by-page and storyline pass, each checked
against the sources: Mercor named in the why-now claim, three kinds of
AI data 'from environments and the expert network', 授权次数 in the
revenue formula, 事件预测 used consistently, tighter data-business and
business-model lines. The team's own wording (bios, problem headline,
Xitadel lines, the hot-spot edge, 失败案例积累, the 商业模式 table)
is kept as written; unsourced '满分100' stays out.

Co-Authored-By: Claude Opus 5.5 <noreply@anthropic.com>
Claude-Session: https://claude.ai/code/session_01EKqGwTA92C8Wo4e47t73NN
</commit_message>
<xml_diff>
--- a/SimReal-BP-v27.pptx
+++ b/SimReal-BP-v27.pptx
@@ -5941,7 +5941,7 @@
                 <a:cs typeface="Instrument Sans"/>
                 <a:sym typeface="Instrument Sans"/>
               </a:rPr>
-              <a:t>面向AI实验室与企业：训练环境、AI数据与评测</a:t>
+              <a:t>面向AI实验室与企业：训练环境、AI数据与自我进化</a:t>
             </a:r>
           </a:p>
         </p:txBody>
@@ -6689,7 +6689,7 @@
                 <a:cs typeface="Newsreader"/>
                 <a:sym typeface="Newsreader"/>
               </a:rPr>
-              <a:t>环境每运行一次，都在产生训练数据：</a:t>
+              <a:t>环境与专家网络，产出三类AI数据：</a:t>
             </a:r>
             <a:r>
               <a:rPr lang="zh-CN" sz="1600" b="0" i="0" u="none" strike="noStrike" cap="none">
@@ -7186,7 +7186,7 @@
                 <a:cs typeface="Instrument Sans"/>
                 <a:sym typeface="Instrument Sans"/>
               </a:rPr>
-              <a:t>来自20万+专家网络：真实工作里的示范、判断与评分标准</a:t>
+              <a:t>背靠20万+专家网络：真实工作里的示范、判断与评分标准</a:t>
             </a:r>
           </a:p>
         </p:txBody>
@@ -7264,7 +7264,7 @@
                 <a:cs typeface="Instrument Sans"/>
                 <a:sym typeface="Instrument Sans"/>
               </a:rPr>
-              <a:t>覆盖各行业入门岗位与前沿科研</a:t>
+              <a:t>覆盖各行业入门岗位与顶尖科研</a:t>
             </a:r>
           </a:p>
         </p:txBody>
@@ -7795,7 +7795,7 @@
                 <a:cs typeface="Instrument Sans"/>
                 <a:sym typeface="Instrument Sans"/>
               </a:rPr>
-              <a:t>同一套环境，同时产出数据、评分与训练</a:t>
+              <a:t>数据、评分与训练，共用一套环境</a:t>
             </a:r>
           </a:p>
         </p:txBody>
@@ -7922,7 +7922,7 @@
                 <a:cs typeface="Instrument Sans"/>
                 <a:sym typeface="Instrument Sans"/>
               </a:rPr>
-              <a:t>轨迹的成败由真实结果判定，不靠人工意见</a:t>
+              <a:t>轨迹成败由真实结果判定，不靠人工意见</a:t>
             </a:r>
           </a:p>
         </p:txBody>
@@ -8049,7 +8049,7 @@
                 <a:cs typeface="Instrument Sans"/>
                 <a:sym typeface="Instrument Sans"/>
               </a:rPr>
-              <a:t>模型在哪里出错，下一批数据就补在哪里</a:t>
+              <a:t>模型错在哪，下一批数据就补到哪</a:t>
             </a:r>
           </a:p>
         </p:txBody>
@@ -8098,7 +8098,7 @@
                 <a:cs typeface="Newsreader"/>
                 <a:sym typeface="Newsreader"/>
               </a:rPr>
-              <a:t>今天实验室每年采购85亿美元训练数据与RL环境：</a:t>
+              <a:t>今天实验室每年花85亿美元买训练数据与RL环境：</a:t>
             </a:r>
             <a:r>
               <a:rPr lang="zh-CN" sz="1800" b="0" i="0" u="none" strike="noStrike" cap="none">
@@ -8110,7 +8110,7 @@
                 <a:cs typeface="Newsreader"/>
                 <a:sym typeface="Newsreader"/>
               </a:rPr>
-              <a:t>数据业务直接进入这个市场</a:t>
+              <a:t>这两样，我们都做</a:t>
             </a:r>
             <a:r>
               <a:rPr lang="zh-CN" sz="1800" b="0" i="0" u="none" strike="noStrike" cap="none">
@@ -9171,7 +9171,7 @@
                 <a:cs typeface="Instrument Sans"/>
                 <a:sym typeface="Instrument Sans"/>
               </a:rPr>
-              <a:t>一个能力目标的环境、数据与评测包</a:t>
+              <a:t>一项能力的环境、数据与评测包</a:t>
             </a:r>
           </a:p>
         </p:txBody>
@@ -9841,7 +9841,7 @@
                 <a:cs typeface="Instrument Sans"/>
                 <a:sym typeface="Instrument Sans"/>
               </a:rPr>
-              <a:t>旧任务会被做饱和，新能力需要新数据</a:t>
+              <a:t>旧任务会饱和，新能力需要新数据</a:t>
             </a:r>
           </a:p>
         </p:txBody>
@@ -10531,7 +10531,7 @@
                 <a:cs typeface="Newsreader"/>
                 <a:sym typeface="Newsreader"/>
               </a:rPr>
-              <a:t>交付之后，仍由我们提供</a:t>
+              <a:t>交付只是开始</a:t>
             </a:r>
           </a:p>
         </p:txBody>
@@ -11627,7 +11627,7 @@
                 <a:cs typeface="Instrument Sans"/>
                 <a:sym typeface="Instrument Sans"/>
               </a:rPr>
-              <a:t>仓库星标合计</a:t>
+              <a:t>GitHub星标合计</a:t>
             </a:r>
           </a:p>
         </p:txBody>
@@ -12320,7 +12320,7 @@
                 <a:cs typeface="IBM Plex Mono"/>
                 <a:sym typeface="IBM Plex Mono"/>
               </a:rPr>
-              <a:t>交易机构从业者支持研发</a:t>
+              <a:t>支持我们研发的交易机构从业者</a:t>
             </a:r>
           </a:p>
         </p:txBody>
@@ -13289,7 +13289,7 @@
                 <a:cs typeface="Newsreader"/>
                 <a:sym typeface="Newsreader"/>
               </a:rPr>
-              <a:t>可触达、可验证的专家，来自</a:t>
+              <a:t>可触达、可验证的专家，来自21所顶尖大学：</a:t>
             </a:r>
             <a:r>
               <a:rPr lang="zh-CN" sz="1600" b="0" i="0" u="none" strike="noStrike" cap="none">
@@ -13301,7 +13301,7 @@
                 <a:cs typeface="Newsreader"/>
                 <a:sym typeface="Newsreader"/>
               </a:rPr>
-              <a:t>21所顶尖大学</a:t>
+              <a:t>专家数据的源头</a:t>
             </a:r>
           </a:p>
         </p:txBody>
@@ -13509,7 +13509,7 @@
                 <a:cs typeface="Instrument Sans"/>
                 <a:sym typeface="Instrument Sans"/>
               </a:rPr>
-              <a:t>顶尖大学网络覆盖</a:t>
+              <a:t>顶尖大学</a:t>
             </a:r>
           </a:p>
         </p:txBody>
@@ -17926,7 +17926,7 @@
                 <a:cs typeface="Instrument Sans"/>
                 <a:sym typeface="Instrument Sans"/>
               </a:rPr>
-              <a:t>同一套环境产出数据、评分与训练</a:t>
+              <a:t>同一套环境打通数据、评分与训练</a:t>
             </a:r>
           </a:p>
           <a:p>
@@ -17952,7 +17952,7 @@
                 <a:cs typeface="Instrument Sans"/>
                 <a:sym typeface="Instrument Sans"/>
               </a:rPr>
-              <a:t>每次结果都变成下一轮训练</a:t>
+              <a:t>每次结果都进入下一轮，AI越练越强</a:t>
             </a:r>
           </a:p>
         </p:txBody>
@@ -18001,7 +18001,7 @@
                 <a:cs typeface="IBM Plex Mono"/>
                 <a:sym typeface="IBM Plex Mono"/>
               </a:rPr>
-              <a:t>为什么我们能赢</a:t>
+              <a:t>我们的优势</a:t>
             </a:r>
           </a:p>
         </p:txBody>
@@ -22692,7 +22692,7 @@
                 <a:cs typeface="Instrument Sans"/>
                 <a:sym typeface="Instrument Sans"/>
               </a:rPr>
-              <a:t>从付费试点推进到环境授权、复购与持续更新合同；数据业务批量交付；实盘交易与事件预测的RSI上线</a:t>
+              <a:t>环境从付费试点推进到授权、复购与持续更新合同；AI数据批量交付；RSI在实盘交易与事件预测上线</a:t>
             </a:r>
           </a:p>
         </p:txBody>
@@ -25014,7 +25014,7 @@
                 <a:cs typeface="Instrument Sans"/>
                 <a:sym typeface="Instrument Sans"/>
               </a:rPr>
-              <a:t>授权、交付与持续更新</a:t>
+              <a:t>接入、验收与持续更新</a:t>
             </a:r>
           </a:p>
         </p:txBody>
@@ -25316,7 +25316,7 @@
                 <a:cs typeface="Newsreader"/>
                 <a:sym typeface="Newsreader"/>
               </a:rPr>
-              <a:t> 卖出次数 </a:t>
+              <a:t> 授权次数 </a:t>
             </a:r>
             <a:r>
               <a:rPr lang="zh-CN" sz="1300" b="0" i="0" u="none" strike="noStrike" cap="none">
@@ -25363,7 +25363,7 @@
                 <a:cs typeface="Instrument Sans"/>
                 <a:sym typeface="Instrument Sans"/>
               </a:rPr>
-              <a:t>环境单价2万–30万美元（Epoch AI）；数据按交付量计</a:t>
+              <a:t>环境单价2万–30万美元（Epoch AI）</a:t>
             </a:r>
           </a:p>
         </p:txBody>
@@ -26468,7 +26468,7 @@
                 <a:cs typeface="Newsreader"/>
                 <a:sym typeface="Newsreader"/>
               </a:rPr>
-              <a:t>实盘交易RSI  ·  预测事件RSI  ·  10个行业</a:t>
+              <a:t>实盘交易RSI  ·  事件预测RSI  ·  10个行业</a:t>
             </a:r>
           </a:p>
           <a:p>
@@ -26716,7 +26716,7 @@
                 <a:cs typeface="Newsreader"/>
                 <a:sym typeface="Newsreader"/>
               </a:rPr>
-              <a:t>预测事件RSI上线</a:t>
+              <a:t>事件预测RSI上线</a:t>
             </a:r>
           </a:p>
         </p:txBody>
@@ -28070,7 +28070,7 @@
                 <a:cs typeface="Instrument Sans"/>
                 <a:sym typeface="Instrument Sans"/>
               </a:rPr>
-              <a:t>面向AI实验室与企业：训练环境、Agent轨迹、</a:t>
+              <a:t>面向AI实验室与企业：Agent轨迹、专家与评测数据</a:t>
             </a:r>
           </a:p>
           <a:p>
@@ -28096,7 +28096,7 @@
                 <a:cs typeface="Instrument Sans"/>
                 <a:sym typeface="Instrument Sans"/>
               </a:rPr>
-              <a:t>专家数据与评测；独家环境让AI自我进化（RSI）</a:t>
+              <a:t>独家环境让AI自我进化（RSI）</a:t>
             </a:r>
           </a:p>
         </p:txBody>
@@ -28480,7 +28480,33 @@
                 <a:cs typeface="Instrument Sans"/>
                 <a:sym typeface="Instrument Sans"/>
               </a:rPr>
-              <a:t>Qwen3.8-27B在Xitadel训练后，在未见过的真实行情上交易表现最高提升12%，多次独立复现</a:t>
+              <a:t>Qwen3.8-27B经Xitadel训练，在未见过的真实行情上</a:t>
+            </a:r>
+          </a:p>
+          <a:p>
+            <a:pPr marL="0" marR="0" lvl="0" indent="0" algn="l" rtl="0">
+              <a:lnSpc>
+                <a:spcPct val="114999"/>
+              </a:lnSpc>
+              <a:spcBef>
+                <a:spcPts val="0"/>
+              </a:spcBef>
+              <a:spcAft>
+                <a:spcPts val="0"/>
+              </a:spcAft>
+              <a:buNone/>
+            </a:pPr>
+            <a:r>
+              <a:rPr lang="zh-CN" sz="1100" b="0" i="0" u="none" strike="noStrike" cap="none">
+                <a:solidFill>
+                  <a:srgbClr val="33322F"/>
+                </a:solidFill>
+                <a:latin typeface="Instrument Sans"/>
+                <a:ea typeface="Instrument Sans"/>
+                <a:cs typeface="Instrument Sans"/>
+                <a:sym typeface="Instrument Sans"/>
+              </a:rPr>
+              <a:t>交易表现最高提升12%，多次独立复现</a:t>
             </a:r>
           </a:p>
         </p:txBody>
@@ -28659,7 +28685,7 @@
                 <a:cs typeface="Instrument Sans"/>
                 <a:sym typeface="Instrument Sans"/>
               </a:rPr>
-              <a:t>剑桥、LSE、杜克本科</a:t>
+              <a:t>剑桥、LSE、杜克数学本科</a:t>
             </a:r>
           </a:p>
           <a:p>
@@ -28914,7 +28940,7 @@
                 <a:cs typeface="Instrument Sans"/>
                 <a:sym typeface="Instrument Sans"/>
               </a:rPr>
-              <a:t>2030年训练市场约7,000亿美元，82倍</a:t>
+              <a:t>2030年训练市场约7,000亿美元，是今天的82倍</a:t>
             </a:r>
           </a:p>
         </p:txBody>
@@ -29093,7 +29119,7 @@
                 <a:cs typeface="Instrument Sans"/>
                 <a:sym typeface="Instrument Sans"/>
               </a:rPr>
-              <a:t>人民币，等值美元投资；投后估值5亿元</a:t>
+              <a:t>人民币（等值美元）；投后估值5亿元</a:t>
             </a:r>
           </a:p>
           <a:p>
@@ -30132,7 +30158,7 @@
                 <a:cs typeface="Instrument Sans"/>
                 <a:sym typeface="Instrument Sans"/>
               </a:rPr>
-              <a:t>Xitadel公开预览版：人类参考分80，前沿模型最高77.28（GPT 6），尚无模型越过人类线</a:t>
+              <a:t>Xitadel公开预览版：人类参考分80，前沿模型最高77.28（GPT 6），尚无模型越过人类水平线</a:t>
             </a:r>
           </a:p>
         </p:txBody>
@@ -30259,7 +30285,7 @@
                 <a:cs typeface="Instrument Sans"/>
                 <a:sym typeface="Instrument Sans"/>
               </a:rPr>
-              <a:t>运行记录、指标定义与脚本，尽调时提供</a:t>
+              <a:t>运行记录、指标定义与脚本</a:t>
             </a:r>
           </a:p>
         </p:txBody>
@@ -30785,7 +30811,7 @@
                 <a:cs typeface="Instrument Sans"/>
                 <a:sym typeface="Instrument Sans"/>
               </a:rPr>
-              <a:t>A轮2.5亿美元（2024年9月）、B轮20亿美元（2025年2月）到C轮100亿美元（2025年10月）；200亿美元估值轮次处于早期洽谈（彭博，2026年7月9日）</a:t>
+              <a:t>A轮2.5亿美元（2024年9月）、B轮20亿美元（2025年2月）、C轮100亿美元（2025年10月）；200亿美元估值轮次处于早期洽谈（彭博，2026年7月9日）</a:t>
             </a:r>
           </a:p>
           <a:p>
@@ -34011,7 +34037,7 @@
                 <a:cs typeface="Instrument Sans"/>
                 <a:sym typeface="Instrument Sans"/>
               </a:rPr>
-              <a:t>汇丰港元稳定币发行项目唯一实习生，全程协助香港金管局（HKMA）合规项目</a:t>
+              <a:t>汇丰港元稳定币发行项目唯一实习生，全程协助推进香港金管局（HKMA）合规项目</a:t>
             </a:r>
           </a:p>
           <a:p>
@@ -35397,7 +35423,7 @@
                 <a:cs typeface="Newsreader"/>
                 <a:sym typeface="Newsreader"/>
               </a:rPr>
-              <a:t>18个月内收入涨27倍、估值涨10倍：</a:t>
+              <a:t>Mercor 18个月内收入涨27倍、估值涨10倍：</a:t>
             </a:r>
             <a:r>
               <a:rPr lang="zh-CN" sz="1600" b="0" i="0" u="none" strike="noStrike" cap="none">
@@ -35845,7 +35871,7 @@
                 <a:cs typeface="IBM Plex Mono"/>
                 <a:sym typeface="IBM Plex Mono"/>
               </a:rPr>
-              <a:t>需求</a:t>
+              <a:t>需求增长</a:t>
             </a:r>
           </a:p>
         </p:txBody>
@@ -35946,7 +35972,7 @@
                 <a:cs typeface="Instrument Sans"/>
                 <a:sym typeface="Instrument Sans"/>
               </a:rPr>
-              <a:t>AI智能体市场：7年，79亿→约1,110亿美元</a:t>
+              <a:t>AI智能体市场预测：7年，79亿→约1,110亿美元</a:t>
             </a:r>
           </a:p>
         </p:txBody>
@@ -36327,7 +36353,7 @@
                 <a:cs typeface="Instrument Sans"/>
                 <a:sym typeface="Instrument Sans"/>
               </a:rPr>
-              <a:t>AfterQuery年化收入突破1亿美元</a:t>
+              <a:t>AfterQuery从成立到年化收入1亿美元</a:t>
             </a:r>
           </a:p>
         </p:txBody>
@@ -38429,7 +38455,7 @@
                 <a:cs typeface="Newsreader"/>
                 <a:sym typeface="Newsreader"/>
               </a:rPr>
-              <a:t>事件揭晓后落空</a:t>
+              <a:t>结果一出就落空</a:t>
             </a:r>
           </a:p>
         </p:txBody>
@@ -39759,7 +39785,7 @@
                 <a:cs typeface="Instrument Sans"/>
                 <a:sym typeface="Instrument Sans"/>
               </a:rPr>
-              <a:t>规则下解题</a:t>
+              <a:t>按答案判对错</a:t>
             </a:r>
           </a:p>
         </p:txBody>
@@ -40192,7 +40218,7 @@
                 <a:cs typeface="Newsreader"/>
                 <a:sym typeface="Newsreader"/>
               </a:rPr>
-              <a:t>真实工作没有标准答案。下一代反馈信号，</a:t>
+              <a:t>考满分的AI，未必能放心交付。下一代反馈信号，</a:t>
             </a:r>
             <a:r>
               <a:rPr lang="zh-CN" sz="2200" b="0" i="0" u="none" strike="noStrike" cap="none">
@@ -40739,7 +40765,7 @@
                 <a:cs typeface="Newsreader"/>
                 <a:sym typeface="Newsreader"/>
               </a:rPr>
-              <a:t>训练环境、</a:t>
+              <a:t>AI完成任务，</a:t>
             </a:r>
             <a:r>
               <a:rPr lang="zh-CN" sz="1600" b="0" i="0" u="none" strike="noStrike" cap="none">
@@ -40751,10 +40777,125 @@
                 <a:cs typeface="Newsreader"/>
                 <a:sym typeface="Newsreader"/>
               </a:rPr>
-              <a:t>结果评分</a:t>
-            </a:r>
-            <a:r>
-              <a:rPr lang="zh-CN" sz="1600" b="0" i="0" u="none" strike="noStrike" cap="none">
+              <a:t>真实结果成为下一轮训练信号</a:t>
+            </a:r>
+          </a:p>
+        </p:txBody>
+      </p:sp>
+      <p:sp>
+        <p:nvSpPr>
+          <p:cNvPr id="5005" name="SimReal 5005"/>
+          <p:cNvSpPr/>
+          <p:nvPr/>
+        </p:nvSpPr>
+        <p:spPr>
+          <a:xfrm>
+            <a:off x="548640" y="1645920"/>
+            <a:ext cx="6035040" cy="594360"/>
+          </a:xfrm>
+          <a:prstGeom prst="rect">
+            <a:avLst/>
+          </a:prstGeom>
+          <a:solidFill>
+            <a:srgbClr val="F2F1EC"/>
+          </a:solidFill>
+          <a:ln>
+            <a:noFill/>
+          </a:ln>
+        </p:spPr>
+        <p:txBody>
+          <a:bodyPr/>
+          <a:lstStyle/>
+          <a:p>
+            <a:endParaRPr/>
+          </a:p>
+        </p:txBody>
+      </p:sp>
+      <p:sp>
+        <p:nvSpPr>
+          <p:cNvPr id="5006" name="SimReal 5006"/>
+          <p:cNvSpPr txBox="1"/>
+          <p:nvPr/>
+        </p:nvSpPr>
+        <p:spPr>
+          <a:xfrm>
+            <a:off x="777240" y="1645920"/>
+            <a:ext cx="457200" cy="594360"/>
+          </a:xfrm>
+          <a:prstGeom prst="rect">
+            <a:avLst/>
+          </a:prstGeom>
+          <a:noFill/>
+          <a:ln>
+            <a:noFill/>
+          </a:ln>
+        </p:spPr>
+        <p:txBody>
+          <a:bodyPr spcFirstLastPara="1" wrap="square" lIns="0" tIns="0" rIns="0" bIns="0" anchor="ctr" anchorCtr="0">
+            <a:noAutofit/>
+          </a:bodyPr>
+          <a:lstStyle/>
+          <a:p>
+            <a:pPr marL="0" marR="0" lvl="0" indent="0" algn="l" rtl="0">
+              <a:spcBef>
+                <a:spcPts val="0"/>
+              </a:spcBef>
+              <a:spcAft>
+                <a:spcPts val="0"/>
+              </a:spcAft>
+              <a:buNone/>
+            </a:pPr>
+            <a:r>
+              <a:rPr lang="zh-CN" sz="1000" b="0" i="0" u="none" strike="noStrike" cap="none">
+                <a:solidFill>
+                  <a:srgbClr val="C2410C"/>
+                </a:solidFill>
+                <a:latin typeface="IBM Plex Mono"/>
+                <a:ea typeface="IBM Plex Mono"/>
+                <a:cs typeface="IBM Plex Mono"/>
+                <a:sym typeface="IBM Plex Mono"/>
+              </a:rPr>
+              <a:t>01</a:t>
+            </a:r>
+          </a:p>
+        </p:txBody>
+      </p:sp>
+      <p:sp>
+        <p:nvSpPr>
+          <p:cNvPr id="5007" name="SimReal 5007"/>
+          <p:cNvSpPr txBox="1"/>
+          <p:nvPr/>
+        </p:nvSpPr>
+        <p:spPr>
+          <a:xfrm>
+            <a:off x="1234440" y="1645920"/>
+            <a:ext cx="1554480" cy="594360"/>
+          </a:xfrm>
+          <a:prstGeom prst="rect">
+            <a:avLst/>
+          </a:prstGeom>
+          <a:noFill/>
+          <a:ln>
+            <a:noFill/>
+          </a:ln>
+        </p:spPr>
+        <p:txBody>
+          <a:bodyPr spcFirstLastPara="1" wrap="square" lIns="0" tIns="0" rIns="0" bIns="0" anchor="ctr" anchorCtr="0">
+            <a:noAutofit/>
+          </a:bodyPr>
+          <a:lstStyle/>
+          <a:p>
+            <a:pPr marL="0" marR="0" lvl="0" indent="0" algn="l" rtl="0">
+              <a:spcBef>
+                <a:spcPts val="0"/>
+              </a:spcBef>
+              <a:spcAft>
+                <a:spcPts val="0"/>
+              </a:spcAft>
+              <a:buNone/>
+            </a:pPr>
+            <a:r>
+              <a:rPr lang="zh-CN" sz="1800" b="0" i="0" u="none" strike="noStrike" cap="none">
                 <a:solidFill>
                   <a:srgbClr val="111110"/>
                 </a:solidFill>
@@ -40763,20 +40904,69 @@
                 <a:cs typeface="Newsreader"/>
                 <a:sym typeface="Newsreader"/>
               </a:rPr>
-              <a:t>与专家反馈：AI完成任务，结果成为下一轮训练信号</a:t>
-            </a:r>
-          </a:p>
-        </p:txBody>
-      </p:sp>
-      <p:sp>
-        <p:nvSpPr>
-          <p:cNvPr id="5005" name="SimReal 5005"/>
+              <a:t>训练环境</a:t>
+            </a:r>
+          </a:p>
+        </p:txBody>
+      </p:sp>
+      <p:sp>
+        <p:nvSpPr>
+          <p:cNvPr id="5008" name="SimReal 5008"/>
+          <p:cNvSpPr txBox="1"/>
+          <p:nvPr/>
+        </p:nvSpPr>
+        <p:spPr>
+          <a:xfrm>
+            <a:off x="2834640" y="1645920"/>
+            <a:ext cx="3566160" cy="594360"/>
+          </a:xfrm>
+          <a:prstGeom prst="rect">
+            <a:avLst/>
+          </a:prstGeom>
+          <a:noFill/>
+          <a:ln>
+            <a:noFill/>
+          </a:ln>
+        </p:spPr>
+        <p:txBody>
+          <a:bodyPr spcFirstLastPara="1" wrap="square" lIns="0" tIns="0" rIns="0" bIns="0" anchor="ctr" anchorCtr="0">
+            <a:noAutofit/>
+          </a:bodyPr>
+          <a:lstStyle/>
+          <a:p>
+            <a:pPr marL="0" marR="0" lvl="0" indent="0" algn="l" rtl="0">
+              <a:spcBef>
+                <a:spcPts val="0"/>
+              </a:spcBef>
+              <a:spcAft>
+                <a:spcPts val="0"/>
+              </a:spcAft>
+              <a:buNone/>
+            </a:pPr>
+            <a:r>
+              <a:rPr lang="zh-CN" sz="1200" b="0" i="0" u="none" strike="noStrike" cap="none">
+                <a:solidFill>
+                  <a:srgbClr val="6E6C66"/>
+                </a:solidFill>
+                <a:latin typeface="Instrument Sans"/>
+                <a:ea typeface="Instrument Sans"/>
+                <a:cs typeface="Instrument Sans"/>
+                <a:sym typeface="Instrument Sans"/>
+              </a:rPr>
+              <a:t>还原真实工作</a:t>
+            </a:r>
+          </a:p>
+        </p:txBody>
+      </p:sp>
+      <p:sp>
+        <p:nvSpPr>
+          <p:cNvPr id="5009" name="SimReal 5009"/>
           <p:cNvSpPr/>
           <p:nvPr/>
         </p:nvSpPr>
         <p:spPr>
           <a:xfrm>
-            <a:off x="548640" y="1645920"/>
+            <a:off x="548640" y="2468880"/>
             <a:ext cx="6035040" cy="594360"/>
           </a:xfrm>
           <a:prstGeom prst="rect">
@@ -40799,13 +40989,13 @@
       </p:sp>
       <p:sp>
         <p:nvSpPr>
-          <p:cNvPr id="5006" name="SimReal 5006"/>
-          <p:cNvSpPr txBox="1"/>
-          <p:nvPr/>
-        </p:nvSpPr>
-        <p:spPr>
-          <a:xfrm>
-            <a:off x="777240" y="1645920"/>
+          <p:cNvPr id="5010" name="SimReal 5010"/>
+          <p:cNvSpPr txBox="1"/>
+          <p:nvPr/>
+        </p:nvSpPr>
+        <p:spPr>
+          <a:xfrm>
+            <a:off x="777240" y="2468880"/>
             <a:ext cx="457200" cy="594360"/>
           </a:xfrm>
           <a:prstGeom prst="rect">
@@ -40841,20 +41031,20 @@
                 <a:cs typeface="IBM Plex Mono"/>
                 <a:sym typeface="IBM Plex Mono"/>
               </a:rPr>
-              <a:t>01</a:t>
-            </a:r>
-          </a:p>
-        </p:txBody>
-      </p:sp>
-      <p:sp>
-        <p:nvSpPr>
-          <p:cNvPr id="5007" name="SimReal 5007"/>
-          <p:cNvSpPr txBox="1"/>
-          <p:nvPr/>
-        </p:nvSpPr>
-        <p:spPr>
-          <a:xfrm>
-            <a:off x="1234440" y="1645920"/>
+              <a:t>02</a:t>
+            </a:r>
+          </a:p>
+        </p:txBody>
+      </p:sp>
+      <p:sp>
+        <p:nvSpPr>
+          <p:cNvPr id="5011" name="SimReal 5011"/>
+          <p:cNvSpPr txBox="1"/>
+          <p:nvPr/>
+        </p:nvSpPr>
+        <p:spPr>
+          <a:xfrm>
+            <a:off x="1234440" y="2468880"/>
             <a:ext cx="1554480" cy="594360"/>
           </a:xfrm>
           <a:prstGeom prst="rect">
@@ -40890,20 +41080,20 @@
                 <a:cs typeface="Newsreader"/>
                 <a:sym typeface="Newsreader"/>
               </a:rPr>
-              <a:t>训练环境</a:t>
-            </a:r>
-          </a:p>
-        </p:txBody>
-      </p:sp>
-      <p:sp>
-        <p:nvSpPr>
-          <p:cNvPr id="5008" name="SimReal 5008"/>
-          <p:cNvSpPr txBox="1"/>
-          <p:nvPr/>
-        </p:nvSpPr>
-        <p:spPr>
-          <a:xfrm>
-            <a:off x="2834640" y="1645920"/>
+              <a:t>结果评分</a:t>
+            </a:r>
+          </a:p>
+        </p:txBody>
+      </p:sp>
+      <p:sp>
+        <p:nvSpPr>
+          <p:cNvPr id="5012" name="SimReal 5012"/>
+          <p:cNvSpPr txBox="1"/>
+          <p:nvPr/>
+        </p:nvSpPr>
+        <p:spPr>
+          <a:xfrm>
+            <a:off x="2834640" y="2468880"/>
             <a:ext cx="3566160" cy="594360"/>
           </a:xfrm>
           <a:prstGeom prst="rect">
@@ -40939,20 +41129,20 @@
                 <a:cs typeface="Instrument Sans"/>
                 <a:sym typeface="Instrument Sans"/>
               </a:rPr>
-              <a:t>还原真实工作</a:t>
-            </a:r>
-          </a:p>
-        </p:txBody>
-      </p:sp>
-      <p:sp>
-        <p:nvSpPr>
-          <p:cNvPr id="5009" name="SimReal 5009"/>
+              <a:t>按真实结果打分，不靠另一个AI的主观判断</a:t>
+            </a:r>
+          </a:p>
+        </p:txBody>
+      </p:sp>
+      <p:sp>
+        <p:nvSpPr>
+          <p:cNvPr id="5013" name="SimReal 5013"/>
           <p:cNvSpPr/>
           <p:nvPr/>
         </p:nvSpPr>
         <p:spPr>
           <a:xfrm>
-            <a:off x="548640" y="2468880"/>
+            <a:off x="548640" y="3291840"/>
             <a:ext cx="6035040" cy="594360"/>
           </a:xfrm>
           <a:prstGeom prst="rect">
@@ -40975,13 +41165,13 @@
       </p:sp>
       <p:sp>
         <p:nvSpPr>
-          <p:cNvPr id="5010" name="SimReal 5010"/>
-          <p:cNvSpPr txBox="1"/>
-          <p:nvPr/>
-        </p:nvSpPr>
-        <p:spPr>
-          <a:xfrm>
-            <a:off x="777240" y="2468880"/>
+          <p:cNvPr id="5014" name="SimReal 5014"/>
+          <p:cNvSpPr txBox="1"/>
+          <p:nvPr/>
+        </p:nvSpPr>
+        <p:spPr>
+          <a:xfrm>
+            <a:off x="777240" y="3291840"/>
             <a:ext cx="457200" cy="594360"/>
           </a:xfrm>
           <a:prstGeom prst="rect">
@@ -41017,20 +41207,20 @@
                 <a:cs typeface="IBM Plex Mono"/>
                 <a:sym typeface="IBM Plex Mono"/>
               </a:rPr>
-              <a:t>02</a:t>
-            </a:r>
-          </a:p>
-        </p:txBody>
-      </p:sp>
-      <p:sp>
-        <p:nvSpPr>
-          <p:cNvPr id="5011" name="SimReal 5011"/>
-          <p:cNvSpPr txBox="1"/>
-          <p:nvPr/>
-        </p:nvSpPr>
-        <p:spPr>
-          <a:xfrm>
-            <a:off x="1234440" y="2468880"/>
+              <a:t>03</a:t>
+            </a:r>
+          </a:p>
+        </p:txBody>
+      </p:sp>
+      <p:sp>
+        <p:nvSpPr>
+          <p:cNvPr id="5015" name="SimReal 5015"/>
+          <p:cNvSpPr txBox="1"/>
+          <p:nvPr/>
+        </p:nvSpPr>
+        <p:spPr>
+          <a:xfrm>
+            <a:off x="1234440" y="3291840"/>
             <a:ext cx="1554480" cy="594360"/>
           </a:xfrm>
           <a:prstGeom prst="rect">
@@ -41066,20 +41256,20 @@
                 <a:cs typeface="Newsreader"/>
                 <a:sym typeface="Newsreader"/>
               </a:rPr>
-              <a:t>结果评分</a:t>
-            </a:r>
-          </a:p>
-        </p:txBody>
-      </p:sp>
-      <p:sp>
-        <p:nvSpPr>
-          <p:cNvPr id="5012" name="SimReal 5012"/>
-          <p:cNvSpPr txBox="1"/>
-          <p:nvPr/>
-        </p:nvSpPr>
-        <p:spPr>
-          <a:xfrm>
-            <a:off x="2834640" y="2468880"/>
+              <a:t>专家反馈</a:t>
+            </a:r>
+          </a:p>
+        </p:txBody>
+      </p:sp>
+      <p:sp>
+        <p:nvSpPr>
+          <p:cNvPr id="5016" name="SimReal 5016"/>
+          <p:cNvSpPr txBox="1"/>
+          <p:nvPr/>
+        </p:nvSpPr>
+        <p:spPr>
+          <a:xfrm>
+            <a:off x="2834640" y="3291840"/>
             <a:ext cx="3566160" cy="594360"/>
           </a:xfrm>
           <a:prstGeom prst="rect">
@@ -41115,27 +41305,27 @@
                 <a:cs typeface="Instrument Sans"/>
                 <a:sym typeface="Instrument Sans"/>
               </a:rPr>
-              <a:t>按真实结果打分，不靠另一个AI的主观判断</a:t>
-            </a:r>
-          </a:p>
-        </p:txBody>
-      </p:sp>
-      <p:sp>
-        <p:nvSpPr>
-          <p:cNvPr id="5013" name="SimReal 5013"/>
+              <a:t>提供专业判断与评分标准</a:t>
+            </a:r>
+          </a:p>
+        </p:txBody>
+      </p:sp>
+      <p:sp>
+        <p:nvSpPr>
+          <p:cNvPr id="5017" name="SimReal 5017"/>
           <p:cNvSpPr/>
           <p:nvPr/>
         </p:nvSpPr>
         <p:spPr>
           <a:xfrm>
-            <a:off x="548640" y="3291840"/>
+            <a:off x="548640" y="4114800"/>
             <a:ext cx="6035040" cy="594360"/>
           </a:xfrm>
           <a:prstGeom prst="rect">
             <a:avLst/>
           </a:prstGeom>
           <a:solidFill>
-            <a:srgbClr val="F2F1EC"/>
+            <a:srgbClr val="111110"/>
           </a:solidFill>
           <a:ln>
             <a:noFill/>
@@ -41151,14 +41341,14 @@
       </p:sp>
       <p:sp>
         <p:nvSpPr>
-          <p:cNvPr id="5014" name="SimReal 5014"/>
-          <p:cNvSpPr txBox="1"/>
-          <p:nvPr/>
-        </p:nvSpPr>
-        <p:spPr>
-          <a:xfrm>
-            <a:off x="777240" y="3291840"/>
-            <a:ext cx="457200" cy="594360"/>
+          <p:cNvPr id="5018" name="SimReal 5018"/>
+          <p:cNvSpPr txBox="1"/>
+          <p:nvPr/>
+        </p:nvSpPr>
+        <p:spPr>
+          <a:xfrm>
+            <a:off x="777240" y="4114800"/>
+            <a:ext cx="2011680" cy="594360"/>
           </a:xfrm>
           <a:prstGeom prst="rect">
             <a:avLst/>
@@ -41186,28 +41376,28 @@
             <a:r>
               <a:rPr lang="zh-CN" sz="1000" b="0" i="0" u="none" strike="noStrike" cap="none">
                 <a:solidFill>
-                  <a:srgbClr val="C2410C"/>
+                  <a:srgbClr val="E27A3F"/>
                 </a:solidFill>
                 <a:latin typeface="IBM Plex Mono"/>
                 <a:ea typeface="IBM Plex Mono"/>
                 <a:cs typeface="IBM Plex Mono"/>
                 <a:sym typeface="IBM Plex Mono"/>
               </a:rPr>
-              <a:t>03</a:t>
-            </a:r>
-          </a:p>
-        </p:txBody>
-      </p:sp>
-      <p:sp>
-        <p:nvSpPr>
-          <p:cNvPr id="5015" name="SimReal 5015"/>
-          <p:cNvSpPr txBox="1"/>
-          <p:nvPr/>
-        </p:nvSpPr>
-        <p:spPr>
-          <a:xfrm>
-            <a:off x="1234440" y="3291840"/>
-            <a:ext cx="1554480" cy="594360"/>
+              <a:t>SimReal</a:t>
+            </a:r>
+          </a:p>
+        </p:txBody>
+      </p:sp>
+      <p:sp>
+        <p:nvSpPr>
+          <p:cNvPr id="5019" name="SimReal 5019"/>
+          <p:cNvSpPr txBox="1"/>
+          <p:nvPr/>
+        </p:nvSpPr>
+        <p:spPr>
+          <a:xfrm>
+            <a:off x="2834640" y="4114800"/>
+            <a:ext cx="3566160" cy="594360"/>
           </a:xfrm>
           <a:prstGeom prst="rect">
             <a:avLst/>
@@ -41233,30 +41423,59 @@
               <a:buNone/>
             </a:pPr>
             <a:r>
-              <a:rPr lang="zh-CN" sz="1800" b="0" i="0" u="none" strike="noStrike" cap="none">
-                <a:solidFill>
-                  <a:srgbClr val="111110"/>
+              <a:rPr lang="zh-CN" sz="1600" b="0" i="0" u="none" strike="noStrike" cap="none">
+                <a:solidFill>
+                  <a:srgbClr val="FAF9F6"/>
                 </a:solidFill>
                 <a:latin typeface="Newsreader"/>
                 <a:ea typeface="Newsreader"/>
                 <a:cs typeface="Newsreader"/>
                 <a:sym typeface="Newsreader"/>
               </a:rPr>
-              <a:t>专家反馈</a:t>
-            </a:r>
-          </a:p>
-        </p:txBody>
-      </p:sp>
-      <p:sp>
-        <p:nvSpPr>
-          <p:cNvPr id="5016" name="SimReal 5016"/>
-          <p:cNvSpPr txBox="1"/>
-          <p:nvPr/>
-        </p:nvSpPr>
-        <p:spPr>
-          <a:xfrm>
-            <a:off x="2834640" y="3291840"/>
-            <a:ext cx="3566160" cy="594360"/>
+              <a:t>同一套环境，打通评测、数据与训练</a:t>
+            </a:r>
+          </a:p>
+        </p:txBody>
+      </p:sp>
+      <p:sp>
+        <p:nvSpPr>
+          <p:cNvPr id="5020" name="SimReal 5020"/>
+          <p:cNvSpPr/>
+          <p:nvPr/>
+        </p:nvSpPr>
+        <p:spPr>
+          <a:xfrm>
+            <a:off x="7086600" y="1645920"/>
+            <a:ext cx="4553712" cy="594360"/>
+          </a:xfrm>
+          <a:prstGeom prst="rect">
+            <a:avLst/>
+          </a:prstGeom>
+          <a:solidFill>
+            <a:srgbClr val="F2F1EC"/>
+          </a:solidFill>
+          <a:ln>
+            <a:noFill/>
+          </a:ln>
+        </p:spPr>
+        <p:txBody>
+          <a:bodyPr/>
+          <a:lstStyle/>
+          <a:p>
+            <a:endParaRPr/>
+          </a:p>
+        </p:txBody>
+      </p:sp>
+      <p:sp>
+        <p:nvSpPr>
+          <p:cNvPr id="5021" name="SimReal 5021"/>
+          <p:cNvSpPr txBox="1"/>
+          <p:nvPr/>
+        </p:nvSpPr>
+        <p:spPr>
+          <a:xfrm>
+            <a:off x="7360920" y="1645920"/>
+            <a:ext cx="4005072" cy="594360"/>
           </a:xfrm>
           <a:prstGeom prst="rect">
             <a:avLst/>
@@ -41282,156 +41501,78 @@
               <a:buNone/>
             </a:pPr>
             <a:r>
-              <a:rPr lang="zh-CN" sz="1200" b="0" i="0" u="none" strike="noStrike" cap="none">
-                <a:solidFill>
-                  <a:srgbClr val="6E6C66"/>
-                </a:solidFill>
-                <a:latin typeface="Instrument Sans"/>
-                <a:ea typeface="Instrument Sans"/>
-                <a:cs typeface="Instrument Sans"/>
-                <a:sym typeface="Instrument Sans"/>
-              </a:rPr>
-              <a:t>提供专业判断与评分标准</a:t>
-            </a:r>
-          </a:p>
-        </p:txBody>
-      </p:sp>
-      <p:sp>
-        <p:nvSpPr>
-          <p:cNvPr id="5017" name="SimReal 5017"/>
-          <p:cNvSpPr/>
-          <p:nvPr/>
-        </p:nvSpPr>
-        <p:spPr>
-          <a:xfrm>
-            <a:off x="548640" y="4114800"/>
-            <a:ext cx="6035040" cy="594360"/>
-          </a:xfrm>
-          <a:prstGeom prst="rect">
-            <a:avLst/>
-          </a:prstGeom>
-          <a:solidFill>
-            <a:srgbClr val="111110"/>
-          </a:solidFill>
-          <a:ln>
-            <a:noFill/>
-          </a:ln>
-        </p:spPr>
-        <p:txBody>
-          <a:bodyPr/>
-          <a:lstStyle/>
-          <a:p>
-            <a:endParaRPr/>
-          </a:p>
-        </p:txBody>
-      </p:sp>
-      <p:sp>
-        <p:nvSpPr>
-          <p:cNvPr id="5018" name="SimReal 5018"/>
-          <p:cNvSpPr txBox="1"/>
-          <p:nvPr/>
-        </p:nvSpPr>
-        <p:spPr>
-          <a:xfrm>
-            <a:off x="777240" y="4114800"/>
-            <a:ext cx="2011680" cy="594360"/>
-          </a:xfrm>
-          <a:prstGeom prst="rect">
-            <a:avLst/>
-          </a:prstGeom>
-          <a:noFill/>
-          <a:ln>
-            <a:noFill/>
-          </a:ln>
-        </p:spPr>
-        <p:txBody>
-          <a:bodyPr spcFirstLastPara="1" wrap="square" lIns="0" tIns="0" rIns="0" bIns="0" anchor="ctr" anchorCtr="0">
-            <a:noAutofit/>
-          </a:bodyPr>
-          <a:lstStyle/>
-          <a:p>
-            <a:pPr marL="0" marR="0" lvl="0" indent="0" algn="l" rtl="0">
-              <a:spcBef>
-                <a:spcPts val="0"/>
-              </a:spcBef>
-              <a:spcAft>
-                <a:spcPts val="0"/>
-              </a:spcAft>
-              <a:buNone/>
-            </a:pPr>
-            <a:r>
-              <a:rPr lang="zh-CN" sz="1000" b="0" i="0" u="none" strike="noStrike" cap="none">
-                <a:solidFill>
-                  <a:srgbClr val="E27A3F"/>
-                </a:solidFill>
-                <a:latin typeface="IBM Plex Mono"/>
-                <a:ea typeface="IBM Plex Mono"/>
-                <a:cs typeface="IBM Plex Mono"/>
-                <a:sym typeface="IBM Plex Mono"/>
-              </a:rPr>
-              <a:t>SimReal</a:t>
-            </a:r>
-          </a:p>
-        </p:txBody>
-      </p:sp>
-      <p:sp>
-        <p:nvSpPr>
-          <p:cNvPr id="5019" name="SimReal 5019"/>
-          <p:cNvSpPr txBox="1"/>
-          <p:nvPr/>
-        </p:nvSpPr>
-        <p:spPr>
-          <a:xfrm>
-            <a:off x="2834640" y="4114800"/>
-            <a:ext cx="3566160" cy="594360"/>
-          </a:xfrm>
-          <a:prstGeom prst="rect">
-            <a:avLst/>
-          </a:prstGeom>
-          <a:noFill/>
-          <a:ln>
-            <a:noFill/>
-          </a:ln>
-        </p:spPr>
-        <p:txBody>
-          <a:bodyPr spcFirstLastPara="1" wrap="square" lIns="0" tIns="0" rIns="0" bIns="0" anchor="ctr" anchorCtr="0">
-            <a:noAutofit/>
-          </a:bodyPr>
-          <a:lstStyle/>
-          <a:p>
-            <a:pPr marL="0" marR="0" lvl="0" indent="0" algn="l" rtl="0">
-              <a:spcBef>
-                <a:spcPts val="0"/>
-              </a:spcBef>
-              <a:spcAft>
-                <a:spcPts val="0"/>
-              </a:spcAft>
-              <a:buNone/>
-            </a:pPr>
-            <a:r>
-              <a:rPr lang="zh-CN" sz="1600" b="0" i="0" u="none" strike="noStrike" cap="none">
-                <a:solidFill>
-                  <a:srgbClr val="FAF9F6"/>
+              <a:rPr lang="zh-CN" sz="1500" b="0" i="0" u="none" strike="noStrike" cap="none">
+                <a:solidFill>
+                  <a:srgbClr val="111110"/>
                 </a:solidFill>
                 <a:latin typeface="Newsreader"/>
                 <a:ea typeface="Newsreader"/>
                 <a:cs typeface="Newsreader"/>
                 <a:sym typeface="Newsreader"/>
               </a:rPr>
-              <a:t>同一套环境，连接评测、数据与训练</a:t>
-            </a:r>
-          </a:p>
-        </p:txBody>
-      </p:sp>
-      <p:sp>
-        <p:nvSpPr>
-          <p:cNvPr id="5020" name="SimReal 5020"/>
+              <a:t>AI行动</a:t>
+            </a:r>
+          </a:p>
+        </p:txBody>
+      </p:sp>
+      <p:sp>
+        <p:nvSpPr>
+          <p:cNvPr id="5022" name="SimReal 5022"/>
+          <p:cNvSpPr txBox="1"/>
+          <p:nvPr/>
+        </p:nvSpPr>
+        <p:spPr>
+          <a:xfrm>
+            <a:off x="7086600" y="2240280"/>
+            <a:ext cx="4553712" cy="228600"/>
+          </a:xfrm>
+          <a:prstGeom prst="rect">
+            <a:avLst/>
+          </a:prstGeom>
+          <a:noFill/>
+          <a:ln>
+            <a:noFill/>
+          </a:ln>
+        </p:spPr>
+        <p:txBody>
+          <a:bodyPr spcFirstLastPara="1" wrap="square" lIns="0" tIns="0" rIns="0" bIns="0" anchor="ctr" anchorCtr="0">
+            <a:noAutofit/>
+          </a:bodyPr>
+          <a:lstStyle/>
+          <a:p>
+            <a:pPr marL="0" marR="0" lvl="0" indent="0" algn="ctr" rtl="0">
+              <a:spcBef>
+                <a:spcPts val="0"/>
+              </a:spcBef>
+              <a:spcAft>
+                <a:spcPts val="0"/>
+              </a:spcAft>
+              <a:buNone/>
+            </a:pPr>
+            <a:r>
+              <a:rPr lang="zh-CN" sz="1100" b="0" i="0" u="none" strike="noStrike" cap="none">
+                <a:solidFill>
+                  <a:srgbClr val="6E6C66"/>
+                </a:solidFill>
+                <a:latin typeface="Instrument Sans"/>
+                <a:ea typeface="Instrument Sans"/>
+                <a:cs typeface="Instrument Sans"/>
+                <a:sym typeface="Instrument Sans"/>
+              </a:rPr>
+              <a:t>↓</a:t>
+            </a:r>
+          </a:p>
+        </p:txBody>
+      </p:sp>
+      <p:sp>
+        <p:nvSpPr>
+          <p:cNvPr id="5023" name="SimReal 5023"/>
           <p:cNvSpPr/>
           <p:nvPr/>
         </p:nvSpPr>
         <p:spPr>
           <a:xfrm>
-            <a:off x="7086600" y="1645920"/>
+            <a:off x="7086600" y="2468880"/>
             <a:ext cx="4553712" cy="594360"/>
           </a:xfrm>
           <a:prstGeom prst="rect">
@@ -41454,13 +41595,13 @@
       </p:sp>
       <p:sp>
         <p:nvSpPr>
-          <p:cNvPr id="5021" name="SimReal 5021"/>
-          <p:cNvSpPr txBox="1"/>
-          <p:nvPr/>
-        </p:nvSpPr>
-        <p:spPr>
-          <a:xfrm>
-            <a:off x="7360920" y="1645920"/>
+          <p:cNvPr id="5024" name="SimReal 5024"/>
+          <p:cNvSpPr txBox="1"/>
+          <p:nvPr/>
+        </p:nvSpPr>
+        <p:spPr>
+          <a:xfrm>
+            <a:off x="7360920" y="2468880"/>
             <a:ext cx="4005072" cy="594360"/>
           </a:xfrm>
           <a:prstGeom prst="rect">
@@ -41496,20 +41637,20 @@
                 <a:cs typeface="Newsreader"/>
                 <a:sym typeface="Newsreader"/>
               </a:rPr>
-              <a:t>AI行动</a:t>
-            </a:r>
-          </a:p>
-        </p:txBody>
-      </p:sp>
-      <p:sp>
-        <p:nvSpPr>
-          <p:cNvPr id="5022" name="SimReal 5022"/>
-          <p:cNvSpPr txBox="1"/>
-          <p:nvPr/>
-        </p:nvSpPr>
-        <p:spPr>
-          <a:xfrm>
-            <a:off x="7086600" y="2240280"/>
+              <a:t>世界给出反馈</a:t>
+            </a:r>
+          </a:p>
+        </p:txBody>
+      </p:sp>
+      <p:sp>
+        <p:nvSpPr>
+          <p:cNvPr id="5025" name="SimReal 5025"/>
+          <p:cNvSpPr txBox="1"/>
+          <p:nvPr/>
+        </p:nvSpPr>
+        <p:spPr>
+          <a:xfrm>
+            <a:off x="7086600" y="3063240"/>
             <a:ext cx="4553712" cy="228600"/>
           </a:xfrm>
           <a:prstGeom prst="rect">
@@ -41552,13 +41693,13 @@
       </p:sp>
       <p:sp>
         <p:nvSpPr>
-          <p:cNvPr id="5023" name="SimReal 5023"/>
+          <p:cNvPr id="5026" name="SimReal 5026"/>
           <p:cNvSpPr/>
           <p:nvPr/>
         </p:nvSpPr>
         <p:spPr>
           <a:xfrm>
-            <a:off x="7086600" y="2468880"/>
+            <a:off x="7086600" y="3291840"/>
             <a:ext cx="4553712" cy="594360"/>
           </a:xfrm>
           <a:prstGeom prst="rect">
@@ -41581,13 +41722,13 @@
       </p:sp>
       <p:sp>
         <p:nvSpPr>
-          <p:cNvPr id="5024" name="SimReal 5024"/>
-          <p:cNvSpPr txBox="1"/>
-          <p:nvPr/>
-        </p:nvSpPr>
-        <p:spPr>
-          <a:xfrm>
-            <a:off x="7360920" y="2468880"/>
+          <p:cNvPr id="5027" name="SimReal 5027"/>
+          <p:cNvSpPr txBox="1"/>
+          <p:nvPr/>
+        </p:nvSpPr>
+        <p:spPr>
+          <a:xfrm>
+            <a:off x="7360920" y="3291840"/>
             <a:ext cx="4005072" cy="594360"/>
           </a:xfrm>
           <a:prstGeom prst="rect">
@@ -41623,134 +41764,7 @@
                 <a:cs typeface="Newsreader"/>
                 <a:sym typeface="Newsreader"/>
               </a:rPr>
-              <a:t>世界给出反馈</a:t>
-            </a:r>
-          </a:p>
-        </p:txBody>
-      </p:sp>
-      <p:sp>
-        <p:nvSpPr>
-          <p:cNvPr id="5025" name="SimReal 5025"/>
-          <p:cNvSpPr txBox="1"/>
-          <p:nvPr/>
-        </p:nvSpPr>
-        <p:spPr>
-          <a:xfrm>
-            <a:off x="7086600" y="3063240"/>
-            <a:ext cx="4553712" cy="228600"/>
-          </a:xfrm>
-          <a:prstGeom prst="rect">
-            <a:avLst/>
-          </a:prstGeom>
-          <a:noFill/>
-          <a:ln>
-            <a:noFill/>
-          </a:ln>
-        </p:spPr>
-        <p:txBody>
-          <a:bodyPr spcFirstLastPara="1" wrap="square" lIns="0" tIns="0" rIns="0" bIns="0" anchor="ctr" anchorCtr="0">
-            <a:noAutofit/>
-          </a:bodyPr>
-          <a:lstStyle/>
-          <a:p>
-            <a:pPr marL="0" marR="0" lvl="0" indent="0" algn="ctr" rtl="0">
-              <a:spcBef>
-                <a:spcPts val="0"/>
-              </a:spcBef>
-              <a:spcAft>
-                <a:spcPts val="0"/>
-              </a:spcAft>
-              <a:buNone/>
-            </a:pPr>
-            <a:r>
-              <a:rPr lang="zh-CN" sz="1100" b="0" i="0" u="none" strike="noStrike" cap="none">
-                <a:solidFill>
-                  <a:srgbClr val="6E6C66"/>
-                </a:solidFill>
-                <a:latin typeface="Instrument Sans"/>
-                <a:ea typeface="Instrument Sans"/>
-                <a:cs typeface="Instrument Sans"/>
-                <a:sym typeface="Instrument Sans"/>
-              </a:rPr>
-              <a:t>↓</a:t>
-            </a:r>
-          </a:p>
-        </p:txBody>
-      </p:sp>
-      <p:sp>
-        <p:nvSpPr>
-          <p:cNvPr id="5026" name="SimReal 5026"/>
-          <p:cNvSpPr/>
-          <p:nvPr/>
-        </p:nvSpPr>
-        <p:spPr>
-          <a:xfrm>
-            <a:off x="7086600" y="3291840"/>
-            <a:ext cx="4553712" cy="594360"/>
-          </a:xfrm>
-          <a:prstGeom prst="rect">
-            <a:avLst/>
-          </a:prstGeom>
-          <a:solidFill>
-            <a:srgbClr val="F2F1EC"/>
-          </a:solidFill>
-          <a:ln>
-            <a:noFill/>
-          </a:ln>
-        </p:spPr>
-        <p:txBody>
-          <a:bodyPr/>
-          <a:lstStyle/>
-          <a:p>
-            <a:endParaRPr/>
-          </a:p>
-        </p:txBody>
-      </p:sp>
-      <p:sp>
-        <p:nvSpPr>
-          <p:cNvPr id="5027" name="SimReal 5027"/>
-          <p:cNvSpPr txBox="1"/>
-          <p:nvPr/>
-        </p:nvSpPr>
-        <p:spPr>
-          <a:xfrm>
-            <a:off x="7360920" y="3291840"/>
-            <a:ext cx="4005072" cy="594360"/>
-          </a:xfrm>
-          <a:prstGeom prst="rect">
-            <a:avLst/>
-          </a:prstGeom>
-          <a:noFill/>
-          <a:ln>
-            <a:noFill/>
-          </a:ln>
-        </p:spPr>
-        <p:txBody>
-          <a:bodyPr spcFirstLastPara="1" wrap="square" lIns="0" tIns="0" rIns="0" bIns="0" anchor="ctr" anchorCtr="0">
-            <a:noAutofit/>
-          </a:bodyPr>
-          <a:lstStyle/>
-          <a:p>
-            <a:pPr marL="0" marR="0" lvl="0" indent="0" algn="l" rtl="0">
-              <a:spcBef>
-                <a:spcPts val="0"/>
-              </a:spcBef>
-              <a:spcAft>
-                <a:spcPts val="0"/>
-              </a:spcAft>
-              <a:buNone/>
-            </a:pPr>
-            <a:r>
-              <a:rPr lang="zh-CN" sz="1500" b="0" i="0" u="none" strike="noStrike" cap="none">
-                <a:solidFill>
-                  <a:srgbClr val="111110"/>
-                </a:solidFill>
-                <a:latin typeface="Newsreader"/>
-                <a:ea typeface="Newsreader"/>
-                <a:cs typeface="Newsreader"/>
-                <a:sym typeface="Newsreader"/>
-              </a:rPr>
-              <a:t>按真实结果评分，留下轨迹数据</a:t>
+              <a:t>按真实结果评分，留下Agent轨迹</a:t>
             </a:r>
           </a:p>
         </p:txBody>

</xml_diff>

<commit_message>
BP v27: fixes from high-resolution visual QA
Even separators on pages 5 and 8 (sans instead of mono), no orphaned
训练/漏洞 on pages 9 and 22, row titles centred on page 12, source lines
on A2 break at clauses instead of inside names, numbers and dates, and
the closing page's corner art no longer touches the logo mark.

Co-Authored-By: Claude Opus 5.5 <noreply@anthropic.com>
Claude-Session: https://claude.ai/code/session_01EKqGwTA92C8Wo4e47t73NN
</commit_message>
<xml_diff>
--- a/SimReal-BP-v27.pptx
+++ b/SimReal-BP-v27.pptx
@@ -7492,7 +7492,22 @@
                 <a:cs typeface="Instrument Sans"/>
                 <a:sym typeface="Instrument Sans"/>
               </a:rPr>
-              <a:t>私有评测集与留出集：只用于检验，从不参与训练</a:t>
+              <a:t>私有评测集与留出集：</a:t>
+            </a:r>
+            <a:br>
+              <a:rPr lang="zh-CN" sz="1150"/>
+            </a:br>
+            <a:r>
+              <a:rPr lang="zh-CN" sz="1150" b="0" i="0" u="none" strike="noStrike" cap="none">
+                <a:solidFill>
+                  <a:srgbClr val="33322F"/>
+                </a:solidFill>
+                <a:latin typeface="Instrument Sans"/>
+                <a:ea typeface="Instrument Sans"/>
+                <a:cs typeface="Instrument Sans"/>
+                <a:sym typeface="Instrument Sans"/>
+              </a:rPr>
+              <a:t>只用于检验，从不参与训练</a:t>
             </a:r>
           </a:p>
         </p:txBody>
@@ -17529,7 +17544,7 @@
         </p:nvSpPr>
         <p:spPr>
           <a:xfrm>
-            <a:off x="777240" y="3209544"/>
+            <a:off x="777240" y="3273552"/>
             <a:ext cx="2377440" cy="365760"/>
           </a:xfrm>
           <a:prstGeom prst="rect">
@@ -17659,7 +17674,7 @@
         </p:nvSpPr>
         <p:spPr>
           <a:xfrm>
-            <a:off x="777240" y="3977640"/>
+            <a:off x="777240" y="4041648"/>
             <a:ext cx="2377440" cy="365760"/>
           </a:xfrm>
           <a:prstGeom prst="rect">
@@ -27063,7 +27078,7 @@
         </p:blipFill>
         <p:spPr>
           <a:xfrm>
-            <a:off x="0" y="0"/>
+            <a:off x="0" y="-137160"/>
             <a:ext cx="1737360" cy="1645920"/>
           </a:xfrm>
           <a:prstGeom prst="rect">
@@ -30773,7 +30788,37 @@
                 <a:cs typeface="Instrument Sans"/>
                 <a:sym typeface="Instrument Sans"/>
               </a:rPr>
-              <a:t>TechCrunch（2025年2月，7,500万美元）；Mercor CEO（2025年9月，5亿美元）；Sacra（2025年12月，7.6亿美元）；Mercor（2026年初，10亿美元）；Dealroom（2026年6月，20亿美元）。均为毛营收，专家拿走60–70%（彭博）</a:t>
+              <a:t>TechCrunch（2025年2月，7,500万美元）；CEO（2025年9月，5亿美元）；</a:t>
+            </a:r>
+            <a:br>
+              <a:rPr lang="zh-CN" sz="900"/>
+            </a:br>
+            <a:r>
+              <a:rPr lang="zh-CN" sz="900" b="0" i="0" u="none" strike="noStrike" cap="none">
+                <a:solidFill>
+                  <a:srgbClr val="33322F"/>
+                </a:solidFill>
+                <a:latin typeface="Instrument Sans"/>
+                <a:ea typeface="Instrument Sans"/>
+                <a:cs typeface="Instrument Sans"/>
+                <a:sym typeface="Instrument Sans"/>
+              </a:rPr>
+              <a:t>Sacra（2025年12月，7.6亿美元）；Mercor（2026年初，10亿美元）；</a:t>
+            </a:r>
+            <a:br>
+              <a:rPr lang="zh-CN" sz="900"/>
+            </a:br>
+            <a:r>
+              <a:rPr lang="zh-CN" sz="900" b="0" i="0" u="none" strike="noStrike" cap="none">
+                <a:solidFill>
+                  <a:srgbClr val="33322F"/>
+                </a:solidFill>
+                <a:latin typeface="Instrument Sans"/>
+                <a:ea typeface="Instrument Sans"/>
+                <a:cs typeface="Instrument Sans"/>
+                <a:sym typeface="Instrument Sans"/>
+              </a:rPr>
+              <a:t>Dealroom（2026年6月，20亿美元）。均为毛营收，专家拿走60–70%（彭博）</a:t>
             </a:r>
           </a:p>
           <a:p>
@@ -30811,7 +30856,22 @@
                 <a:cs typeface="Instrument Sans"/>
                 <a:sym typeface="Instrument Sans"/>
               </a:rPr>
-              <a:t>A轮2.5亿美元（2024年9月）、B轮20亿美元（2025年2月）、C轮100亿美元（2025年10月）；200亿美元估值轮次处于早期洽谈（彭博，2026年7月9日）</a:t>
+              <a:t>A轮2.5亿（2024年9月）、B轮20亿（2025年2月）、C轮100亿美元（2025年10月）；</a:t>
+            </a:r>
+            <a:br>
+              <a:rPr lang="zh-CN" sz="900"/>
+            </a:br>
+            <a:r>
+              <a:rPr lang="zh-CN" sz="900" b="0" i="0" u="none" strike="noStrike" cap="none">
+                <a:solidFill>
+                  <a:srgbClr val="33322F"/>
+                </a:solidFill>
+                <a:latin typeface="Instrument Sans"/>
+                <a:ea typeface="Instrument Sans"/>
+                <a:cs typeface="Instrument Sans"/>
+                <a:sym typeface="Instrument Sans"/>
+              </a:rPr>
+              <a:t>200亿美元估值轮次处于早期洽谈（彭博，2026年7月9日）</a:t>
             </a:r>
           </a:p>
           <a:p>
@@ -30887,7 +30947,22 @@
                 <a:cs typeface="Instrument Sans"/>
                 <a:sym typeface="Instrument Sans"/>
               </a:rPr>
-              <a:t>公司公告及TechCrunch，2026年9月22日（以35亿美元估值融资3.5亿美元；年化收入3.75亿美元，一年增长18倍）</a:t>
+              <a:t>公司公告及TechCrunch，2026年9月22日（以35亿美元估值融资3.5亿美元；</a:t>
+            </a:r>
+            <a:br>
+              <a:rPr lang="zh-CN" sz="900"/>
+            </a:br>
+            <a:r>
+              <a:rPr lang="zh-CN" sz="900" b="0" i="0" u="none" strike="noStrike" cap="none">
+                <a:solidFill>
+                  <a:srgbClr val="33322F"/>
+                </a:solidFill>
+                <a:latin typeface="Instrument Sans"/>
+                <a:ea typeface="Instrument Sans"/>
+                <a:cs typeface="Instrument Sans"/>
+                <a:sym typeface="Instrument Sans"/>
+              </a:rPr>
+              <a:t>年化收入3.75亿美元，一年增长18倍）</a:t>
             </a:r>
           </a:p>
           <a:p>
@@ -30925,7 +31000,37 @@
                 <a:cs typeface="Instrument Sans"/>
                 <a:sym typeface="Instrument Sans"/>
               </a:rPr>
-              <a:t>2025年2月成立；福布斯，2026年9月1日（加入YC 18个月，估值32亿美元）；Business Wire（2026年4月，A轮估值3亿美元，年化收入1亿美元）；YC公司页（联合创始人曾在Citadel Securities实习）</a:t>
+              <a:t>2025年2月成立；福布斯，2026年9月1日（加入YC 18个月，估值32亿美元）；</a:t>
+            </a:r>
+            <a:br>
+              <a:rPr lang="zh-CN" sz="900"/>
+            </a:br>
+            <a:r>
+              <a:rPr lang="zh-CN" sz="900" b="0" i="0" u="none" strike="noStrike" cap="none">
+                <a:solidFill>
+                  <a:srgbClr val="33322F"/>
+                </a:solidFill>
+                <a:latin typeface="Instrument Sans"/>
+                <a:ea typeface="Instrument Sans"/>
+                <a:cs typeface="Instrument Sans"/>
+                <a:sym typeface="Instrument Sans"/>
+              </a:rPr>
+              <a:t>Business Wire（2026年4月，A轮估值3亿美元，年化收入1亿美元）；</a:t>
+            </a:r>
+            <a:br>
+              <a:rPr lang="zh-CN" sz="900"/>
+            </a:br>
+            <a:r>
+              <a:rPr lang="zh-CN" sz="900" b="0" i="0" u="none" strike="noStrike" cap="none">
+                <a:solidFill>
+                  <a:srgbClr val="33322F"/>
+                </a:solidFill>
+                <a:latin typeface="Instrument Sans"/>
+                <a:ea typeface="Instrument Sans"/>
+                <a:cs typeface="Instrument Sans"/>
+                <a:sym typeface="Instrument Sans"/>
+              </a:rPr>
+              <a:t>YC公司页（联合创始人曾在Citadel Securities实习）</a:t>
             </a:r>
           </a:p>
           <a:p>
@@ -31386,7 +31491,22 @@
                 <a:cs typeface="Instrument Sans"/>
                 <a:sym typeface="Instrument Sans"/>
               </a:rPr>
-              <a:t>Epoch AI《Will we run out of data?》（2024）：预计2026–2032年间用尽（80%置信区间）</a:t>
+              <a:t>Epoch AI《Will we run out of data?》（2024）：</a:t>
+            </a:r>
+            <a:br>
+              <a:rPr lang="zh-CN" sz="900"/>
+            </a:br>
+            <a:r>
+              <a:rPr lang="zh-CN" sz="900" b="0" i="0" u="none" strike="noStrike" cap="none">
+                <a:solidFill>
+                  <a:srgbClr val="33322F"/>
+                </a:solidFill>
+                <a:latin typeface="Instrument Sans"/>
+                <a:ea typeface="Instrument Sans"/>
+                <a:cs typeface="Instrument Sans"/>
+                <a:sym typeface="Instrument Sans"/>
+              </a:rPr>
+              <a:t>预计2026–2032年间用尽（80%置信区间）</a:t>
             </a:r>
           </a:p>
           <a:p>
@@ -31424,7 +31544,22 @@
                 <a:cs typeface="Instrument Sans"/>
                 <a:sym typeface="Instrument Sans"/>
               </a:rPr>
-              <a:t>Applied Compute：Upstarts（2025年6月，种子轮2,000万美元，投后1亿美元）、The Information（2026年8月，约30亿美元洽谈）</a:t>
+              <a:t>Applied Compute：Upstarts（2025年6月，种子轮2,000万美元，投后1亿美元）；</a:t>
+            </a:r>
+            <a:br>
+              <a:rPr lang="zh-CN" sz="900"/>
+            </a:br>
+            <a:r>
+              <a:rPr lang="zh-CN" sz="900" b="0" i="0" u="none" strike="noStrike" cap="none">
+                <a:solidFill>
+                  <a:srgbClr val="33322F"/>
+                </a:solidFill>
+                <a:latin typeface="Instrument Sans"/>
+                <a:ea typeface="Instrument Sans"/>
+                <a:cs typeface="Instrument Sans"/>
+                <a:sym typeface="Instrument Sans"/>
+              </a:rPr>
+              <a:t>The Information（2026年8月，约30亿美元洽谈）</a:t>
             </a:r>
           </a:p>
         </p:txBody>
@@ -32815,7 +32950,7 @@
                 <a:cs typeface="Instrument Sans"/>
                 <a:sym typeface="Instrument Sans"/>
               </a:rPr>
-              <a:t>上线前模拟作弊与攻击，找出并修补评分漏洞</a:t>
+              <a:t>上线前模拟作弊与攻击，修补评分漏洞</a:t>
             </a:r>
           </a:p>
         </p:txBody>
@@ -39165,10 +39300,10 @@
                 <a:solidFill>
                   <a:srgbClr val="6E6C66"/>
                 </a:solidFill>
-                <a:latin typeface="IBM Plex Mono"/>
-                <a:ea typeface="IBM Plex Mono"/>
-                <a:cs typeface="IBM Plex Mono"/>
-                <a:sym typeface="IBM Plex Mono"/>
+                <a:latin typeface="Instrument Sans"/>
+                <a:ea typeface="Instrument Sans"/>
+                <a:cs typeface="Instrument Sans"/>
+                <a:sym typeface="Instrument Sans"/>
               </a:rPr>
               <a:t>第一代 · 互联网数据</a:t>
             </a:r>
@@ -39422,10 +39557,10 @@
                 <a:solidFill>
                   <a:srgbClr val="6E6C66"/>
                 </a:solidFill>
-                <a:latin typeface="IBM Plex Mono"/>
-                <a:ea typeface="IBM Plex Mono"/>
-                <a:cs typeface="IBM Plex Mono"/>
-                <a:sym typeface="IBM Plex Mono"/>
+                <a:latin typeface="Instrument Sans"/>
+                <a:ea typeface="Instrument Sans"/>
+                <a:cs typeface="Instrument Sans"/>
+                <a:sym typeface="Instrument Sans"/>
               </a:rPr>
               <a:t>第二代 · 人类偏好</a:t>
             </a:r>
@@ -39679,10 +39814,10 @@
                 <a:solidFill>
                   <a:srgbClr val="6E6C66"/>
                 </a:solidFill>
-                <a:latin typeface="IBM Plex Mono"/>
-                <a:ea typeface="IBM Plex Mono"/>
-                <a:cs typeface="IBM Plex Mono"/>
-                <a:sym typeface="IBM Plex Mono"/>
+                <a:latin typeface="Instrument Sans"/>
+                <a:ea typeface="Instrument Sans"/>
+                <a:cs typeface="Instrument Sans"/>
+                <a:sym typeface="Instrument Sans"/>
               </a:rPr>
               <a:t>第三代 · 标准答案</a:t>
             </a:r>
@@ -39936,10 +40071,10 @@
                 <a:solidFill>
                   <a:srgbClr val="E27A3F"/>
                 </a:solidFill>
-                <a:latin typeface="IBM Plex Mono"/>
-                <a:ea typeface="IBM Plex Mono"/>
-                <a:cs typeface="IBM Plex Mono"/>
-                <a:sym typeface="IBM Plex Mono"/>
+                <a:latin typeface="Instrument Sans"/>
+                <a:ea typeface="Instrument Sans"/>
+                <a:cs typeface="Instrument Sans"/>
+                <a:sym typeface="Instrument Sans"/>
               </a:rPr>
               <a:t>第四代 · 真实世界的反馈</a:t>
             </a:r>
@@ -46535,10 +46670,10 @@
                 <a:solidFill>
                   <a:srgbClr val="6E6C66"/>
                 </a:solidFill>
-                <a:latin typeface="IBM Plex Mono"/>
-                <a:ea typeface="IBM Plex Mono"/>
-                <a:cs typeface="IBM Plex Mono"/>
-                <a:sym typeface="IBM Plex Mono"/>
+                <a:latin typeface="Instrument Sans"/>
+                <a:ea typeface="Instrument Sans"/>
+                <a:cs typeface="Instrument Sans"/>
+                <a:sym typeface="Instrument Sans"/>
               </a:rPr>
               <a:t>合计400星标  ·  2026年9月29日</a:t>
             </a:r>

</xml_diff>